<commit_message>
Close up the day
</commit_message>
<xml_diff>
--- a/meetings/Kazakhstan Delegation.pptx
+++ b/meetings/Kazakhstan Delegation.pptx
@@ -184,7 +184,6 @@
 <file path=ppt/revisionInfo.xml><?xml version="1.0" encoding="utf-8"?>
 <p1510:revInfo xmlns:a="http://schemas.openxmlformats.org/drawingml/2006/main" xmlns:r="http://schemas.openxmlformats.org/officeDocument/2006/relationships" xmlns:p1510="http://schemas.microsoft.com/office/powerpoint/2015/10/main">
   <p1510:revLst>
-    <p1510:client id="{820570CC-6446-884E-9E93-5434CF496813}" v="3" dt="2026-06-23T19:30:11.364"/>
     <p1510:client id="{8F7C090C-987E-824D-B1BB-FC32991BBC78}" v="2" dt="2026-06-23T22:14:17.222"/>
   </p1510:revLst>
 </p1510:revInfo>
@@ -194,17 +193,429 @@
 <pc:chgInfo xmlns:a="http://schemas.openxmlformats.org/drawingml/2006/main" xmlns:r="http://schemas.openxmlformats.org/officeDocument/2006/relationships" xmlns:ac="http://schemas.microsoft.com/office/drawing/2013/main/command" xmlns:pc="http://schemas.microsoft.com/office/powerpoint/2013/main/command">
   <pc:docChgLst>
     <pc:chgData name="David O'Hara" userId="8f90669b-8651-42ab-8d95-20602fbdf8e8" providerId="ADAL" clId="{A236AE32-B983-55C9-B7CE-2378BA1C83AB}"/>
-    <pc:docChg chg="modSld">
-      <pc:chgData name="David O'Hara" userId="8f90669b-8651-42ab-8d95-20602fbdf8e8" providerId="ADAL" clId="{A236AE32-B983-55C9-B7CE-2378BA1C83AB}" dt="2026-06-23T22:14:36.453" v="13" actId="20577"/>
+    <pc:docChg chg="undo custSel modSld">
+      <pc:chgData name="David O'Hara" userId="8f90669b-8651-42ab-8d95-20602fbdf8e8" providerId="ADAL" clId="{A236AE32-B983-55C9-B7CE-2378BA1C83AB}" dt="2026-06-26T18:53:56.704" v="143" actId="113"/>
       <pc:docMkLst>
         <pc:docMk/>
       </pc:docMkLst>
-      <pc:sldChg chg="modNotesTx">
-        <pc:chgData name="David O'Hara" userId="8f90669b-8651-42ab-8d95-20602fbdf8e8" providerId="ADAL" clId="{A236AE32-B983-55C9-B7CE-2378BA1C83AB}" dt="2026-06-23T22:14:36.453" v="13" actId="20577"/>
+      <pc:sldChg chg="modSp mod">
+        <pc:chgData name="David O'Hara" userId="8f90669b-8651-42ab-8d95-20602fbdf8e8" providerId="ADAL" clId="{A236AE32-B983-55C9-B7CE-2378BA1C83AB}" dt="2026-06-26T18:49:19.045" v="16" actId="14100"/>
+        <pc:sldMkLst>
+          <pc:docMk/>
+          <pc:sldMk cId="51378315" sldId="256"/>
+        </pc:sldMkLst>
+        <pc:spChg chg="mod">
+          <ac:chgData name="David O'Hara" userId="8f90669b-8651-42ab-8d95-20602fbdf8e8" providerId="ADAL" clId="{A236AE32-B983-55C9-B7CE-2378BA1C83AB}" dt="2026-06-26T18:49:19.045" v="16" actId="14100"/>
+          <ac:spMkLst>
+            <pc:docMk/>
+            <pc:sldMk cId="51378315" sldId="256"/>
+            <ac:spMk id="2" creationId="{00000000-0000-0000-0000-000000000000}"/>
+          </ac:spMkLst>
+        </pc:spChg>
+        <pc:spChg chg="mod">
+          <ac:chgData name="David O'Hara" userId="8f90669b-8651-42ab-8d95-20602fbdf8e8" providerId="ADAL" clId="{A236AE32-B983-55C9-B7CE-2378BA1C83AB}" dt="2026-06-26T18:49:19.045" v="16" actId="14100"/>
+          <ac:spMkLst>
+            <pc:docMk/>
+            <pc:sldMk cId="51378315" sldId="256"/>
+            <ac:spMk id="7" creationId="{00000000-0000-0000-0000-000000000000}"/>
+          </ac:spMkLst>
+        </pc:spChg>
+        <pc:spChg chg="mod">
+          <ac:chgData name="David O'Hara" userId="8f90669b-8651-42ab-8d95-20602fbdf8e8" providerId="ADAL" clId="{A236AE32-B983-55C9-B7CE-2378BA1C83AB}" dt="2026-06-26T18:49:19.045" v="16" actId="14100"/>
+          <ac:spMkLst>
+            <pc:docMk/>
+            <pc:sldMk cId="51378315" sldId="256"/>
+            <ac:spMk id="8" creationId="{00000000-0000-0000-0000-000000000000}"/>
+          </ac:spMkLst>
+        </pc:spChg>
+        <pc:spChg chg="mod">
+          <ac:chgData name="David O'Hara" userId="8f90669b-8651-42ab-8d95-20602fbdf8e8" providerId="ADAL" clId="{A236AE32-B983-55C9-B7CE-2378BA1C83AB}" dt="2026-06-26T18:49:19.045" v="16" actId="14100"/>
+          <ac:spMkLst>
+            <pc:docMk/>
+            <pc:sldMk cId="51378315" sldId="256"/>
+            <ac:spMk id="9" creationId="{00000000-0000-0000-0000-000000000000}"/>
+          </ac:spMkLst>
+        </pc:spChg>
+        <pc:spChg chg="mod">
+          <ac:chgData name="David O'Hara" userId="8f90669b-8651-42ab-8d95-20602fbdf8e8" providerId="ADAL" clId="{A236AE32-B983-55C9-B7CE-2378BA1C83AB}" dt="2026-06-26T18:49:19.045" v="16" actId="14100"/>
+          <ac:spMkLst>
+            <pc:docMk/>
+            <pc:sldMk cId="51378315" sldId="256"/>
+            <ac:spMk id="10" creationId="{00000000-0000-0000-0000-000000000000}"/>
+          </ac:spMkLst>
+        </pc:spChg>
+        <pc:spChg chg="mod">
+          <ac:chgData name="David O'Hara" userId="8f90669b-8651-42ab-8d95-20602fbdf8e8" providerId="ADAL" clId="{A236AE32-B983-55C9-B7CE-2378BA1C83AB}" dt="2026-06-26T18:49:19.045" v="16" actId="14100"/>
+          <ac:spMkLst>
+            <pc:docMk/>
+            <pc:sldMk cId="51378315" sldId="256"/>
+            <ac:spMk id="11" creationId="{00000000-0000-0000-0000-000000000000}"/>
+          </ac:spMkLst>
+        </pc:spChg>
+        <pc:spChg chg="mod">
+          <ac:chgData name="David O'Hara" userId="8f90669b-8651-42ab-8d95-20602fbdf8e8" providerId="ADAL" clId="{A236AE32-B983-55C9-B7CE-2378BA1C83AB}" dt="2026-06-26T18:49:19.045" v="16" actId="14100"/>
+          <ac:spMkLst>
+            <pc:docMk/>
+            <pc:sldMk cId="51378315" sldId="256"/>
+            <ac:spMk id="12" creationId="{00000000-0000-0000-0000-000000000000}"/>
+          </ac:spMkLst>
+        </pc:spChg>
+        <pc:spChg chg="mod">
+          <ac:chgData name="David O'Hara" userId="8f90669b-8651-42ab-8d95-20602fbdf8e8" providerId="ADAL" clId="{A236AE32-B983-55C9-B7CE-2378BA1C83AB}" dt="2026-06-26T18:49:19.045" v="16" actId="14100"/>
+          <ac:spMkLst>
+            <pc:docMk/>
+            <pc:sldMk cId="51378315" sldId="256"/>
+            <ac:spMk id="13" creationId="{00000000-0000-0000-0000-000000000000}"/>
+          </ac:spMkLst>
+        </pc:spChg>
+        <pc:spChg chg="mod">
+          <ac:chgData name="David O'Hara" userId="8f90669b-8651-42ab-8d95-20602fbdf8e8" providerId="ADAL" clId="{A236AE32-B983-55C9-B7CE-2378BA1C83AB}" dt="2026-06-26T18:49:19.045" v="16" actId="14100"/>
+          <ac:spMkLst>
+            <pc:docMk/>
+            <pc:sldMk cId="51378315" sldId="256"/>
+            <ac:spMk id="14" creationId="{00000000-0000-0000-0000-000000000000}"/>
+          </ac:spMkLst>
+        </pc:spChg>
+        <pc:spChg chg="mod">
+          <ac:chgData name="David O'Hara" userId="8f90669b-8651-42ab-8d95-20602fbdf8e8" providerId="ADAL" clId="{A236AE32-B983-55C9-B7CE-2378BA1C83AB}" dt="2026-06-26T18:49:19.045" v="16" actId="14100"/>
+          <ac:spMkLst>
+            <pc:docMk/>
+            <pc:sldMk cId="51378315" sldId="256"/>
+            <ac:spMk id="15" creationId="{00000000-0000-0000-0000-000000000000}"/>
+          </ac:spMkLst>
+        </pc:spChg>
+      </pc:sldChg>
+      <pc:sldChg chg="delSp mod">
+        <pc:chgData name="David O'Hara" userId="8f90669b-8651-42ab-8d95-20602fbdf8e8" providerId="ADAL" clId="{A236AE32-B983-55C9-B7CE-2378BA1C83AB}" dt="2026-06-26T18:48:53.836" v="14" actId="478"/>
+        <pc:sldMkLst>
+          <pc:docMk/>
+          <pc:sldMk cId="0" sldId="275"/>
+        </pc:sldMkLst>
+        <pc:spChg chg="del">
+          <ac:chgData name="David O'Hara" userId="8f90669b-8651-42ab-8d95-20602fbdf8e8" providerId="ADAL" clId="{A236AE32-B983-55C9-B7CE-2378BA1C83AB}" dt="2026-06-26T18:48:53.836" v="14" actId="478"/>
+          <ac:spMkLst>
+            <pc:docMk/>
+            <pc:sldMk cId="0" sldId="275"/>
+            <ac:spMk id="13" creationId="{00000000-0000-0000-0000-000000000000}"/>
+          </ac:spMkLst>
+        </pc:spChg>
+        <pc:spChg chg="del">
+          <ac:chgData name="David O'Hara" userId="8f90669b-8651-42ab-8d95-20602fbdf8e8" providerId="ADAL" clId="{A236AE32-B983-55C9-B7CE-2378BA1C83AB}" dt="2026-06-26T18:48:53.836" v="14" actId="478"/>
+          <ac:spMkLst>
+            <pc:docMk/>
+            <pc:sldMk cId="0" sldId="275"/>
+            <ac:spMk id="14" creationId="{00000000-0000-0000-0000-000000000000}"/>
+          </ac:spMkLst>
+        </pc:spChg>
+      </pc:sldChg>
+      <pc:sldChg chg="modSp mod modNotesTx">
+        <pc:chgData name="David O'Hara" userId="8f90669b-8651-42ab-8d95-20602fbdf8e8" providerId="ADAL" clId="{A236AE32-B983-55C9-B7CE-2378BA1C83AB}" dt="2026-06-26T18:53:56.704" v="143" actId="113"/>
         <pc:sldMkLst>
           <pc:docMk/>
           <pc:sldMk cId="0" sldId="276"/>
         </pc:sldMkLst>
+        <pc:spChg chg="mod">
+          <ac:chgData name="David O'Hara" userId="8f90669b-8651-42ab-8d95-20602fbdf8e8" providerId="ADAL" clId="{A236AE32-B983-55C9-B7CE-2378BA1C83AB}" dt="2026-06-26T18:53:14.857" v="131" actId="403"/>
+          <ac:spMkLst>
+            <pc:docMk/>
+            <pc:sldMk cId="0" sldId="276"/>
+            <ac:spMk id="9" creationId="{00000000-0000-0000-0000-000000000000}"/>
+          </ac:spMkLst>
+        </pc:spChg>
+        <pc:spChg chg="mod">
+          <ac:chgData name="David O'Hara" userId="8f90669b-8651-42ab-8d95-20602fbdf8e8" providerId="ADAL" clId="{A236AE32-B983-55C9-B7CE-2378BA1C83AB}" dt="2026-06-26T18:53:29.461" v="134" actId="113"/>
+          <ac:spMkLst>
+            <pc:docMk/>
+            <pc:sldMk cId="0" sldId="276"/>
+            <ac:spMk id="10" creationId="{00000000-0000-0000-0000-000000000000}"/>
+          </ac:spMkLst>
+        </pc:spChg>
+        <pc:spChg chg="mod">
+          <ac:chgData name="David O'Hara" userId="8f90669b-8651-42ab-8d95-20602fbdf8e8" providerId="ADAL" clId="{A236AE32-B983-55C9-B7CE-2378BA1C83AB}" dt="2026-06-26T18:53:14.857" v="131" actId="403"/>
+          <ac:spMkLst>
+            <pc:docMk/>
+            <pc:sldMk cId="0" sldId="276"/>
+            <ac:spMk id="13" creationId="{00000000-0000-0000-0000-000000000000}"/>
+          </ac:spMkLst>
+        </pc:spChg>
+        <pc:spChg chg="mod">
+          <ac:chgData name="David O'Hara" userId="8f90669b-8651-42ab-8d95-20602fbdf8e8" providerId="ADAL" clId="{A236AE32-B983-55C9-B7CE-2378BA1C83AB}" dt="2026-06-26T18:53:36.828" v="137" actId="113"/>
+          <ac:spMkLst>
+            <pc:docMk/>
+            <pc:sldMk cId="0" sldId="276"/>
+            <ac:spMk id="14" creationId="{00000000-0000-0000-0000-000000000000}"/>
+          </ac:spMkLst>
+        </pc:spChg>
+        <pc:spChg chg="mod">
+          <ac:chgData name="David O'Hara" userId="8f90669b-8651-42ab-8d95-20602fbdf8e8" providerId="ADAL" clId="{A236AE32-B983-55C9-B7CE-2378BA1C83AB}" dt="2026-06-26T18:53:14.857" v="131" actId="403"/>
+          <ac:spMkLst>
+            <pc:docMk/>
+            <pc:sldMk cId="0" sldId="276"/>
+            <ac:spMk id="17" creationId="{00000000-0000-0000-0000-000000000000}"/>
+          </ac:spMkLst>
+        </pc:spChg>
+        <pc:spChg chg="mod">
+          <ac:chgData name="David O'Hara" userId="8f90669b-8651-42ab-8d95-20602fbdf8e8" providerId="ADAL" clId="{A236AE32-B983-55C9-B7CE-2378BA1C83AB}" dt="2026-06-26T18:53:56.704" v="143" actId="113"/>
+          <ac:spMkLst>
+            <pc:docMk/>
+            <pc:sldMk cId="0" sldId="276"/>
+            <ac:spMk id="18" creationId="{00000000-0000-0000-0000-000000000000}"/>
+          </ac:spMkLst>
+        </pc:spChg>
+        <pc:spChg chg="mod">
+          <ac:chgData name="David O'Hara" userId="8f90669b-8651-42ab-8d95-20602fbdf8e8" providerId="ADAL" clId="{A236AE32-B983-55C9-B7CE-2378BA1C83AB}" dt="2026-06-26T18:53:14.857" v="131" actId="403"/>
+          <ac:spMkLst>
+            <pc:docMk/>
+            <pc:sldMk cId="0" sldId="276"/>
+            <ac:spMk id="21" creationId="{00000000-0000-0000-0000-000000000000}"/>
+          </ac:spMkLst>
+        </pc:spChg>
+        <pc:spChg chg="mod">
+          <ac:chgData name="David O'Hara" userId="8f90669b-8651-42ab-8d95-20602fbdf8e8" providerId="ADAL" clId="{A236AE32-B983-55C9-B7CE-2378BA1C83AB}" dt="2026-06-26T18:53:45.440" v="140" actId="113"/>
+          <ac:spMkLst>
+            <pc:docMk/>
+            <pc:sldMk cId="0" sldId="276"/>
+            <ac:spMk id="22" creationId="{00000000-0000-0000-0000-000000000000}"/>
+          </ac:spMkLst>
+        </pc:spChg>
+      </pc:sldChg>
+      <pc:sldChg chg="modSp mod">
+        <pc:chgData name="David O'Hara" userId="8f90669b-8651-42ab-8d95-20602fbdf8e8" providerId="ADAL" clId="{A236AE32-B983-55C9-B7CE-2378BA1C83AB}" dt="2026-06-26T18:51:27.739" v="67" actId="404"/>
+        <pc:sldMkLst>
+          <pc:docMk/>
+          <pc:sldMk cId="313602034" sldId="283"/>
+        </pc:sldMkLst>
+        <pc:spChg chg="mod">
+          <ac:chgData name="David O'Hara" userId="8f90669b-8651-42ab-8d95-20602fbdf8e8" providerId="ADAL" clId="{A236AE32-B983-55C9-B7CE-2378BA1C83AB}" dt="2026-06-26T18:50:48.022" v="50" actId="403"/>
+          <ac:spMkLst>
+            <pc:docMk/>
+            <pc:sldMk cId="313602034" sldId="283"/>
+            <ac:spMk id="4" creationId="{00000000-0000-0000-0000-000000000000}"/>
+          </ac:spMkLst>
+        </pc:spChg>
+        <pc:spChg chg="mod">
+          <ac:chgData name="David O'Hara" userId="8f90669b-8651-42ab-8d95-20602fbdf8e8" providerId="ADAL" clId="{A236AE32-B983-55C9-B7CE-2378BA1C83AB}" dt="2026-06-26T18:51:27.739" v="67" actId="404"/>
+          <ac:spMkLst>
+            <pc:docMk/>
+            <pc:sldMk cId="313602034" sldId="283"/>
+            <ac:spMk id="6" creationId="{00000000-0000-0000-0000-000000000000}"/>
+          </ac:spMkLst>
+        </pc:spChg>
+        <pc:spChg chg="mod">
+          <ac:chgData name="David O'Hara" userId="8f90669b-8651-42ab-8d95-20602fbdf8e8" providerId="ADAL" clId="{A236AE32-B983-55C9-B7CE-2378BA1C83AB}" dt="2026-06-26T18:51:10.105" v="65" actId="403"/>
+          <ac:spMkLst>
+            <pc:docMk/>
+            <pc:sldMk cId="313602034" sldId="283"/>
+            <ac:spMk id="7" creationId="{00000000-0000-0000-0000-000000000000}"/>
+          </ac:spMkLst>
+        </pc:spChg>
+        <pc:spChg chg="mod">
+          <ac:chgData name="David O'Hara" userId="8f90669b-8651-42ab-8d95-20602fbdf8e8" providerId="ADAL" clId="{A236AE32-B983-55C9-B7CE-2378BA1C83AB}" dt="2026-06-26T18:50:48.022" v="50" actId="403"/>
+          <ac:spMkLst>
+            <pc:docMk/>
+            <pc:sldMk cId="313602034" sldId="283"/>
+            <ac:spMk id="8" creationId="{00000000-0000-0000-0000-000000000000}"/>
+          </ac:spMkLst>
+        </pc:spChg>
+        <pc:spChg chg="mod">
+          <ac:chgData name="David O'Hara" userId="8f90669b-8651-42ab-8d95-20602fbdf8e8" providerId="ADAL" clId="{A236AE32-B983-55C9-B7CE-2378BA1C83AB}" dt="2026-06-26T18:51:27.739" v="67" actId="404"/>
+          <ac:spMkLst>
+            <pc:docMk/>
+            <pc:sldMk cId="313602034" sldId="283"/>
+            <ac:spMk id="10" creationId="{00000000-0000-0000-0000-000000000000}"/>
+          </ac:spMkLst>
+        </pc:spChg>
+        <pc:spChg chg="mod">
+          <ac:chgData name="David O'Hara" userId="8f90669b-8651-42ab-8d95-20602fbdf8e8" providerId="ADAL" clId="{A236AE32-B983-55C9-B7CE-2378BA1C83AB}" dt="2026-06-26T18:51:10.105" v="65" actId="403"/>
+          <ac:spMkLst>
+            <pc:docMk/>
+            <pc:sldMk cId="313602034" sldId="283"/>
+            <ac:spMk id="11" creationId="{00000000-0000-0000-0000-000000000000}"/>
+          </ac:spMkLst>
+        </pc:spChg>
+        <pc:spChg chg="mod">
+          <ac:chgData name="David O'Hara" userId="8f90669b-8651-42ab-8d95-20602fbdf8e8" providerId="ADAL" clId="{A236AE32-B983-55C9-B7CE-2378BA1C83AB}" dt="2026-06-26T18:50:48.022" v="50" actId="403"/>
+          <ac:spMkLst>
+            <pc:docMk/>
+            <pc:sldMk cId="313602034" sldId="283"/>
+            <ac:spMk id="12" creationId="{00000000-0000-0000-0000-000000000000}"/>
+          </ac:spMkLst>
+        </pc:spChg>
+        <pc:spChg chg="mod">
+          <ac:chgData name="David O'Hara" userId="8f90669b-8651-42ab-8d95-20602fbdf8e8" providerId="ADAL" clId="{A236AE32-B983-55C9-B7CE-2378BA1C83AB}" dt="2026-06-26T18:51:27.739" v="67" actId="404"/>
+          <ac:spMkLst>
+            <pc:docMk/>
+            <pc:sldMk cId="313602034" sldId="283"/>
+            <ac:spMk id="14" creationId="{00000000-0000-0000-0000-000000000000}"/>
+          </ac:spMkLst>
+        </pc:spChg>
+        <pc:spChg chg="mod">
+          <ac:chgData name="David O'Hara" userId="8f90669b-8651-42ab-8d95-20602fbdf8e8" providerId="ADAL" clId="{A236AE32-B983-55C9-B7CE-2378BA1C83AB}" dt="2026-06-26T18:51:10.105" v="65" actId="403"/>
+          <ac:spMkLst>
+            <pc:docMk/>
+            <pc:sldMk cId="313602034" sldId="283"/>
+            <ac:spMk id="15" creationId="{00000000-0000-0000-0000-000000000000}"/>
+          </ac:spMkLst>
+        </pc:spChg>
+        <pc:spChg chg="mod">
+          <ac:chgData name="David O'Hara" userId="8f90669b-8651-42ab-8d95-20602fbdf8e8" providerId="ADAL" clId="{A236AE32-B983-55C9-B7CE-2378BA1C83AB}" dt="2026-06-26T18:50:38.306" v="47" actId="1036"/>
+          <ac:spMkLst>
+            <pc:docMk/>
+            <pc:sldMk cId="313602034" sldId="283"/>
+            <ac:spMk id="16" creationId="{00000000-0000-0000-0000-000000000000}"/>
+          </ac:spMkLst>
+        </pc:spChg>
+        <pc:spChg chg="mod">
+          <ac:chgData name="David O'Hara" userId="8f90669b-8651-42ab-8d95-20602fbdf8e8" providerId="ADAL" clId="{A236AE32-B983-55C9-B7CE-2378BA1C83AB}" dt="2026-06-26T18:50:38.306" v="47" actId="1036"/>
+          <ac:spMkLst>
+            <pc:docMk/>
+            <pc:sldMk cId="313602034" sldId="283"/>
+            <ac:spMk id="17" creationId="{00000000-0000-0000-0000-000000000000}"/>
+          </ac:spMkLst>
+        </pc:spChg>
+      </pc:sldChg>
+      <pc:sldChg chg="modSp mod">
+        <pc:chgData name="David O'Hara" userId="8f90669b-8651-42ab-8d95-20602fbdf8e8" providerId="ADAL" clId="{A236AE32-B983-55C9-B7CE-2378BA1C83AB}" dt="2026-06-26T18:52:40.514" v="126" actId="14100"/>
+        <pc:sldMkLst>
+          <pc:docMk/>
+          <pc:sldMk cId="0" sldId="284"/>
+        </pc:sldMkLst>
+        <pc:spChg chg="mod">
+          <ac:chgData name="David O'Hara" userId="8f90669b-8651-42ab-8d95-20602fbdf8e8" providerId="ADAL" clId="{A236AE32-B983-55C9-B7CE-2378BA1C83AB}" dt="2026-06-26T18:52:40.514" v="126" actId="14100"/>
+          <ac:spMkLst>
+            <pc:docMk/>
+            <pc:sldMk cId="0" sldId="284"/>
+            <ac:spMk id="4" creationId="{00000000-0000-0000-0000-000000000000}"/>
+          </ac:spMkLst>
+        </pc:spChg>
+        <pc:spChg chg="mod">
+          <ac:chgData name="David O'Hara" userId="8f90669b-8651-42ab-8d95-20602fbdf8e8" providerId="ADAL" clId="{A236AE32-B983-55C9-B7CE-2378BA1C83AB}" dt="2026-06-26T18:52:40.514" v="126" actId="14100"/>
+          <ac:spMkLst>
+            <pc:docMk/>
+            <pc:sldMk cId="0" sldId="284"/>
+            <ac:spMk id="5" creationId="{00000000-0000-0000-0000-000000000000}"/>
+          </ac:spMkLst>
+        </pc:spChg>
+        <pc:spChg chg="mod">
+          <ac:chgData name="David O'Hara" userId="8f90669b-8651-42ab-8d95-20602fbdf8e8" providerId="ADAL" clId="{A236AE32-B983-55C9-B7CE-2378BA1C83AB}" dt="2026-06-26T18:52:40.514" v="126" actId="14100"/>
+          <ac:spMkLst>
+            <pc:docMk/>
+            <pc:sldMk cId="0" sldId="284"/>
+            <ac:spMk id="6" creationId="{00000000-0000-0000-0000-000000000000}"/>
+          </ac:spMkLst>
+        </pc:spChg>
+        <pc:spChg chg="mod">
+          <ac:chgData name="David O'Hara" userId="8f90669b-8651-42ab-8d95-20602fbdf8e8" providerId="ADAL" clId="{A236AE32-B983-55C9-B7CE-2378BA1C83AB}" dt="2026-06-26T18:52:40.514" v="126" actId="14100"/>
+          <ac:spMkLst>
+            <pc:docMk/>
+            <pc:sldMk cId="0" sldId="284"/>
+            <ac:spMk id="7" creationId="{00000000-0000-0000-0000-000000000000}"/>
+          </ac:spMkLst>
+        </pc:spChg>
+        <pc:spChg chg="mod">
+          <ac:chgData name="David O'Hara" userId="8f90669b-8651-42ab-8d95-20602fbdf8e8" providerId="ADAL" clId="{A236AE32-B983-55C9-B7CE-2378BA1C83AB}" dt="2026-06-26T18:52:40.514" v="126" actId="14100"/>
+          <ac:spMkLst>
+            <pc:docMk/>
+            <pc:sldMk cId="0" sldId="284"/>
+            <ac:spMk id="8" creationId="{00000000-0000-0000-0000-000000000000}"/>
+          </ac:spMkLst>
+        </pc:spChg>
+        <pc:spChg chg="mod">
+          <ac:chgData name="David O'Hara" userId="8f90669b-8651-42ab-8d95-20602fbdf8e8" providerId="ADAL" clId="{A236AE32-B983-55C9-B7CE-2378BA1C83AB}" dt="2026-06-26T18:52:40.514" v="126" actId="14100"/>
+          <ac:spMkLst>
+            <pc:docMk/>
+            <pc:sldMk cId="0" sldId="284"/>
+            <ac:spMk id="9" creationId="{00000000-0000-0000-0000-000000000000}"/>
+          </ac:spMkLst>
+        </pc:spChg>
+        <pc:spChg chg="mod">
+          <ac:chgData name="David O'Hara" userId="8f90669b-8651-42ab-8d95-20602fbdf8e8" providerId="ADAL" clId="{A236AE32-B983-55C9-B7CE-2378BA1C83AB}" dt="2026-06-26T18:52:40.514" v="126" actId="14100"/>
+          <ac:spMkLst>
+            <pc:docMk/>
+            <pc:sldMk cId="0" sldId="284"/>
+            <ac:spMk id="10" creationId="{00000000-0000-0000-0000-000000000000}"/>
+          </ac:spMkLst>
+        </pc:spChg>
+        <pc:spChg chg="mod">
+          <ac:chgData name="David O'Hara" userId="8f90669b-8651-42ab-8d95-20602fbdf8e8" providerId="ADAL" clId="{A236AE32-B983-55C9-B7CE-2378BA1C83AB}" dt="2026-06-26T18:52:40.514" v="126" actId="14100"/>
+          <ac:spMkLst>
+            <pc:docMk/>
+            <pc:sldMk cId="0" sldId="284"/>
+            <ac:spMk id="11" creationId="{00000000-0000-0000-0000-000000000000}"/>
+          </ac:spMkLst>
+        </pc:spChg>
+        <pc:spChg chg="mod">
+          <ac:chgData name="David O'Hara" userId="8f90669b-8651-42ab-8d95-20602fbdf8e8" providerId="ADAL" clId="{A236AE32-B983-55C9-B7CE-2378BA1C83AB}" dt="2026-06-26T18:52:40.514" v="126" actId="14100"/>
+          <ac:spMkLst>
+            <pc:docMk/>
+            <pc:sldMk cId="0" sldId="284"/>
+            <ac:spMk id="12" creationId="{00000000-0000-0000-0000-000000000000}"/>
+          </ac:spMkLst>
+        </pc:spChg>
+        <pc:spChg chg="mod">
+          <ac:chgData name="David O'Hara" userId="8f90669b-8651-42ab-8d95-20602fbdf8e8" providerId="ADAL" clId="{A236AE32-B983-55C9-B7CE-2378BA1C83AB}" dt="2026-06-26T18:52:40.514" v="126" actId="14100"/>
+          <ac:spMkLst>
+            <pc:docMk/>
+            <pc:sldMk cId="0" sldId="284"/>
+            <ac:spMk id="13" creationId="{00000000-0000-0000-0000-000000000000}"/>
+          </ac:spMkLst>
+        </pc:spChg>
+        <pc:spChg chg="mod">
+          <ac:chgData name="David O'Hara" userId="8f90669b-8651-42ab-8d95-20602fbdf8e8" providerId="ADAL" clId="{A236AE32-B983-55C9-B7CE-2378BA1C83AB}" dt="2026-06-26T18:52:29.433" v="125" actId="1036"/>
+          <ac:spMkLst>
+            <pc:docMk/>
+            <pc:sldMk cId="0" sldId="284"/>
+            <ac:spMk id="14" creationId="{00000000-0000-0000-0000-000000000000}"/>
+          </ac:spMkLst>
+        </pc:spChg>
+        <pc:spChg chg="mod">
+          <ac:chgData name="David O'Hara" userId="8f90669b-8651-42ab-8d95-20602fbdf8e8" providerId="ADAL" clId="{A236AE32-B983-55C9-B7CE-2378BA1C83AB}" dt="2026-06-26T18:52:29.433" v="125" actId="1036"/>
+          <ac:spMkLst>
+            <pc:docMk/>
+            <pc:sldMk cId="0" sldId="284"/>
+            <ac:spMk id="15" creationId="{00000000-0000-0000-0000-000000000000}"/>
+          </ac:spMkLst>
+        </pc:spChg>
+        <pc:spChg chg="mod">
+          <ac:chgData name="David O'Hara" userId="8f90669b-8651-42ab-8d95-20602fbdf8e8" providerId="ADAL" clId="{A236AE32-B983-55C9-B7CE-2378BA1C83AB}" dt="2026-06-26T18:52:29.433" v="125" actId="1036"/>
+          <ac:spMkLst>
+            <pc:docMk/>
+            <pc:sldMk cId="0" sldId="284"/>
+            <ac:spMk id="16" creationId="{00000000-0000-0000-0000-000000000000}"/>
+          </ac:spMkLst>
+        </pc:spChg>
+        <pc:spChg chg="mod">
+          <ac:chgData name="David O'Hara" userId="8f90669b-8651-42ab-8d95-20602fbdf8e8" providerId="ADAL" clId="{A236AE32-B983-55C9-B7CE-2378BA1C83AB}" dt="2026-06-26T18:52:29.433" v="125" actId="1036"/>
+          <ac:spMkLst>
+            <pc:docMk/>
+            <pc:sldMk cId="0" sldId="284"/>
+            <ac:spMk id="17" creationId="{00000000-0000-0000-0000-000000000000}"/>
+          </ac:spMkLst>
+        </pc:spChg>
+        <pc:spChg chg="mod">
+          <ac:chgData name="David O'Hara" userId="8f90669b-8651-42ab-8d95-20602fbdf8e8" providerId="ADAL" clId="{A236AE32-B983-55C9-B7CE-2378BA1C83AB}" dt="2026-06-26T18:52:29.433" v="125" actId="1036"/>
+          <ac:spMkLst>
+            <pc:docMk/>
+            <pc:sldMk cId="0" sldId="284"/>
+            <ac:spMk id="18" creationId="{00000000-0000-0000-0000-000000000000}"/>
+          </ac:spMkLst>
+        </pc:spChg>
+        <pc:spChg chg="mod">
+          <ac:chgData name="David O'Hara" userId="8f90669b-8651-42ab-8d95-20602fbdf8e8" providerId="ADAL" clId="{A236AE32-B983-55C9-B7CE-2378BA1C83AB}" dt="2026-06-26T18:52:29.433" v="125" actId="1036"/>
+          <ac:spMkLst>
+            <pc:docMk/>
+            <pc:sldMk cId="0" sldId="284"/>
+            <ac:spMk id="19" creationId="{00000000-0000-0000-0000-000000000000}"/>
+          </ac:spMkLst>
+        </pc:spChg>
+        <pc:spChg chg="mod">
+          <ac:chgData name="David O'Hara" userId="8f90669b-8651-42ab-8d95-20602fbdf8e8" providerId="ADAL" clId="{A236AE32-B983-55C9-B7CE-2378BA1C83AB}" dt="2026-06-26T18:52:09.823" v="84" actId="1076"/>
+          <ac:spMkLst>
+            <pc:docMk/>
+            <pc:sldMk cId="0" sldId="284"/>
+            <ac:spMk id="20" creationId="{00000000-0000-0000-0000-000000000000}"/>
+          </ac:spMkLst>
+        </pc:spChg>
       </pc:sldChg>
     </pc:docChg>
   </pc:docChgLst>
@@ -305,7 +716,7 @@
           <a:p>
             <a:fld id="{FA586793-C8A1-F947-908B-E0EDCF860903}" type="datetimeFigureOut">
               <a:rPr lang="en-US" smtClean="0"/>
-              <a:t>6/23/26</a:t>
+              <a:t>6/26/26</a:t>
             </a:fld>
             <a:endParaRPr lang="en-US"/>
           </a:p>
@@ -482,7 +893,7 @@
           <a:p>
             <a:fld id="{E1A18E33-7982-7242-B011-19D9B39AC4BA}" type="datetimeFigureOut">
               <a:rPr lang="en-MX" smtClean="0"/>
-              <a:t>6/23/26</a:t>
+              <a:t>6/26/26</a:t>
             </a:fld>
             <a:endParaRPr lang="en-MX"/>
           </a:p>
@@ -1267,7 +1678,7 @@
           <a:p>
             <a:fld id="{BBA207E0-E171-4508-927B-82D6F3BC81AA}" type="datetimeFigureOut">
               <a:rPr lang="en-US" smtClean="0"/>
-              <a:t>6/23/26</a:t>
+              <a:t>6/26/26</a:t>
             </a:fld>
             <a:endParaRPr lang="en-US"/>
           </a:p>
@@ -3761,7 +4172,7 @@
         <p:spPr>
           <a:xfrm>
             <a:off x="365760" y="1371600"/>
-            <a:ext cx="3566160" cy="2514600"/>
+            <a:ext cx="3566160" cy="3854614"/>
           </a:xfrm>
           <a:prstGeom prst="rect">
             <a:avLst/>
@@ -3780,7 +4191,7 @@
           <a:bodyPr/>
           <a:lstStyle/>
           <a:p>
-            <a:endParaRPr lang="en-US"/>
+            <a:endParaRPr lang="en-US" sz="2400"/>
           </a:p>
         </p:txBody>
       </p:sp>
@@ -3841,7 +4252,7 @@
               <a:buNone/>
             </a:pPr>
             <a:r>
-              <a:rPr lang="en-US" sz="1300" b="1" dirty="0">
+              <a:rPr lang="en-US" sz="1600" b="1" dirty="0">
                 <a:solidFill>
                   <a:srgbClr val="005596"/>
                 </a:solidFill>
@@ -3851,7 +4262,7 @@
               </a:rPr>
               <a:t>Wrong Budget Allocation</a:t>
             </a:r>
-            <a:endParaRPr lang="en-US" sz="1300" dirty="0"/>
+            <a:endParaRPr lang="en-US" sz="1600" dirty="0"/>
           </a:p>
         </p:txBody>
       </p:sp>
@@ -3863,8 +4274,8 @@
         </p:nvSpPr>
         <p:spPr>
           <a:xfrm>
-            <a:off x="530352" y="2084832"/>
-            <a:ext cx="3246120" cy="1691640"/>
+            <a:off x="530352" y="2181817"/>
+            <a:ext cx="3246120" cy="2729902"/>
           </a:xfrm>
           <a:prstGeom prst="rect">
             <a:avLst/>
@@ -3883,7 +4294,7 @@
               <a:buNone/>
             </a:pPr>
             <a:r>
-              <a:rPr lang="en-US" sz="1200" dirty="0">
+              <a:rPr lang="en-US" sz="2400" dirty="0">
                 <a:solidFill>
                   <a:srgbClr val="444444"/>
                 </a:solidFill>
@@ -3893,7 +4304,7 @@
               </a:rPr>
               <a:t>50%+ of GenAI spend targets sales &amp; marketing — but the biggest ROI is in back-office operations and finance.</a:t>
             </a:r>
-            <a:endParaRPr lang="en-US" sz="1200" dirty="0"/>
+            <a:endParaRPr lang="en-US" sz="2400" dirty="0"/>
           </a:p>
         </p:txBody>
       </p:sp>
@@ -3906,7 +4317,7 @@
         <p:spPr>
           <a:xfrm>
             <a:off x="4206240" y="1371600"/>
-            <a:ext cx="3566160" cy="2514600"/>
+            <a:ext cx="3566160" cy="3854614"/>
           </a:xfrm>
           <a:prstGeom prst="rect">
             <a:avLst/>
@@ -3925,7 +4336,7 @@
           <a:bodyPr/>
           <a:lstStyle/>
           <a:p>
-            <a:endParaRPr lang="en-US"/>
+            <a:endParaRPr lang="en-US" sz="2400"/>
           </a:p>
         </p:txBody>
       </p:sp>
@@ -3986,7 +4397,7 @@
               <a:buNone/>
             </a:pPr>
             <a:r>
-              <a:rPr lang="en-US" sz="1300" b="1" dirty="0">
+              <a:rPr lang="en-US" sz="1600" b="1" dirty="0">
                 <a:solidFill>
                   <a:srgbClr val="005596"/>
                 </a:solidFill>
@@ -3996,7 +4407,7 @@
               </a:rPr>
               <a:t>Internal Builds Underperform</a:t>
             </a:r>
-            <a:endParaRPr lang="en-US" sz="1300" dirty="0"/>
+            <a:endParaRPr lang="en-US" sz="1600" dirty="0"/>
           </a:p>
         </p:txBody>
       </p:sp>
@@ -4008,8 +4419,8 @@
         </p:nvSpPr>
         <p:spPr>
           <a:xfrm>
-            <a:off x="4370832" y="2084832"/>
-            <a:ext cx="3246120" cy="1691640"/>
+            <a:off x="4370832" y="2181817"/>
+            <a:ext cx="3246120" cy="2729902"/>
           </a:xfrm>
           <a:prstGeom prst="rect">
             <a:avLst/>
@@ -4028,7 +4439,7 @@
               <a:buNone/>
             </a:pPr>
             <a:r>
-              <a:rPr lang="en-US" sz="1200" dirty="0">
+              <a:rPr lang="en-US" sz="2400" dirty="0">
                 <a:solidFill>
                   <a:srgbClr val="444444"/>
                 </a:solidFill>
@@ -4038,7 +4449,7 @@
               </a:rPr>
               <a:t>Vendor-built AI succeeds 67% of the time. Internal builds succeed only 1/3 as often. Buying beats building.</a:t>
             </a:r>
-            <a:endParaRPr lang="en-US" sz="1200" dirty="0"/>
+            <a:endParaRPr lang="en-US" sz="2400" dirty="0"/>
           </a:p>
         </p:txBody>
       </p:sp>
@@ -4051,7 +4462,7 @@
         <p:spPr>
           <a:xfrm>
             <a:off x="8046720" y="1371600"/>
-            <a:ext cx="3566160" cy="2514600"/>
+            <a:ext cx="3566160" cy="3854614"/>
           </a:xfrm>
           <a:prstGeom prst="rect">
             <a:avLst/>
@@ -4070,7 +4481,7 @@
           <a:bodyPr/>
           <a:lstStyle/>
           <a:p>
-            <a:endParaRPr lang="en-US"/>
+            <a:endParaRPr lang="en-US" sz="2400"/>
           </a:p>
         </p:txBody>
       </p:sp>
@@ -4131,7 +4542,7 @@
               <a:buNone/>
             </a:pPr>
             <a:r>
-              <a:rPr lang="en-US" sz="1300" b="1" dirty="0">
+              <a:rPr lang="en-US" sz="1600" b="1" dirty="0">
                 <a:solidFill>
                   <a:srgbClr val="005596"/>
                 </a:solidFill>
@@ -4141,7 +4552,7 @@
               </a:rPr>
               <a:t>Enterprises Move Too Slow</a:t>
             </a:r>
-            <a:endParaRPr lang="en-US" sz="1300" dirty="0"/>
+            <a:endParaRPr lang="en-US" sz="1600" dirty="0"/>
           </a:p>
         </p:txBody>
       </p:sp>
@@ -4153,8 +4564,8 @@
         </p:nvSpPr>
         <p:spPr>
           <a:xfrm>
-            <a:off x="8211312" y="2084832"/>
-            <a:ext cx="3246120" cy="1691640"/>
+            <a:off x="8211312" y="2181817"/>
+            <a:ext cx="3246120" cy="2729902"/>
           </a:xfrm>
           <a:prstGeom prst="rect">
             <a:avLst/>
@@ -4173,7 +4584,7 @@
               <a:buNone/>
             </a:pPr>
             <a:r>
-              <a:rPr lang="en-US" sz="1200" dirty="0">
+              <a:rPr lang="en-US" sz="2400" dirty="0">
                 <a:solidFill>
                   <a:srgbClr val="444444"/>
                 </a:solidFill>
@@ -4183,7 +4594,7 @@
               </a:rPr>
               <a:t>Mid-market reaches full deployment in ~90 days. Large enterprises take 9+ months — and convert fewer pilots.</a:t>
             </a:r>
-            <a:endParaRPr lang="en-US" sz="1200" dirty="0"/>
+            <a:endParaRPr lang="en-US" sz="2400" dirty="0"/>
           </a:p>
         </p:txBody>
       </p:sp>
@@ -4195,7 +4606,7 @@
         </p:nvSpPr>
         <p:spPr>
           <a:xfrm>
-            <a:off x="365760" y="4023360"/>
+            <a:off x="365760" y="5436526"/>
             <a:ext cx="11612880" cy="658368"/>
           </a:xfrm>
           <a:prstGeom prst="rect">
@@ -4227,7 +4638,7 @@
         </p:nvSpPr>
         <p:spPr>
           <a:xfrm>
-            <a:off x="594360" y="4078224"/>
+            <a:off x="594360" y="5491390"/>
             <a:ext cx="11155680" cy="548640"/>
           </a:xfrm>
           <a:prstGeom prst="rect">
@@ -4374,8 +4785,8 @@
         </p:nvSpPr>
         <p:spPr>
           <a:xfrm>
-            <a:off x="365760" y="1353312"/>
-            <a:ext cx="5486400" cy="1572768"/>
+            <a:off x="365759" y="1353312"/>
+            <a:ext cx="5519651" cy="2168508"/>
           </a:xfrm>
           <a:prstGeom prst="rect">
             <a:avLst/>
@@ -4406,8 +4817,8 @@
         </p:nvSpPr>
         <p:spPr>
           <a:xfrm>
-            <a:off x="530352" y="1463040"/>
-            <a:ext cx="640080" cy="457200"/>
+            <a:off x="530351" y="1463040"/>
+            <a:ext cx="643959" cy="630380"/>
           </a:xfrm>
           <a:prstGeom prst="rect">
             <a:avLst/>
@@ -4445,8 +4856,8 @@
         </p:nvSpPr>
         <p:spPr>
           <a:xfrm>
-            <a:off x="1234440" y="1481328"/>
-            <a:ext cx="4434840" cy="347472"/>
+            <a:off x="1234440" y="1481327"/>
+            <a:ext cx="4461718" cy="479089"/>
           </a:xfrm>
           <a:prstGeom prst="rect">
             <a:avLst/>
@@ -4462,7 +4873,7 @@
               <a:buNone/>
             </a:pPr>
             <a:r>
-              <a:rPr lang="en-US" sz="1300" b="1" dirty="0">
+              <a:rPr lang="en-US" b="1" dirty="0">
                 <a:solidFill>
                   <a:srgbClr val="4597D3"/>
                 </a:solidFill>
@@ -4472,7 +4883,7 @@
               </a:rPr>
               <a:t>Line Managers Drive Adoption</a:t>
             </a:r>
-            <a:endParaRPr lang="en-US" sz="1300" dirty="0"/>
+            <a:endParaRPr lang="en-US" dirty="0"/>
           </a:p>
         </p:txBody>
       </p:sp>
@@ -4485,7 +4896,7 @@
         <p:spPr>
           <a:xfrm>
             <a:off x="1234440" y="1874520"/>
-            <a:ext cx="4434840" cy="960120"/>
+            <a:ext cx="4461718" cy="1323798"/>
           </a:xfrm>
           <a:prstGeom prst="rect">
             <a:avLst/>
@@ -4504,7 +4915,7 @@
               <a:buNone/>
             </a:pPr>
             <a:r>
-              <a:rPr lang="en-US" sz="1100" dirty="0">
+              <a:rPr lang="en-US" dirty="0">
                 <a:solidFill>
                   <a:srgbClr val="DDDDDD"/>
                 </a:solidFill>
@@ -4514,7 +4925,7 @@
               </a:rPr>
               <a:t>Not central AI labs or CoEs. Frontline managers own AI integration — not a dedicated center of excellence.</a:t>
             </a:r>
-            <a:endParaRPr lang="en-US" sz="1100" dirty="0"/>
+            <a:endParaRPr lang="en-US" dirty="0"/>
           </a:p>
         </p:txBody>
       </p:sp>
@@ -4526,8 +4937,8 @@
         </p:nvSpPr>
         <p:spPr>
           <a:xfrm>
-            <a:off x="6035040" y="1353312"/>
-            <a:ext cx="5486400" cy="1572768"/>
+            <a:off x="6035039" y="1353312"/>
+            <a:ext cx="5519651" cy="2168508"/>
           </a:xfrm>
           <a:prstGeom prst="rect">
             <a:avLst/>
@@ -4558,8 +4969,8 @@
         </p:nvSpPr>
         <p:spPr>
           <a:xfrm>
-            <a:off x="6199632" y="1463040"/>
-            <a:ext cx="640080" cy="457200"/>
+            <a:off x="6199631" y="1463040"/>
+            <a:ext cx="643959" cy="630380"/>
           </a:xfrm>
           <a:prstGeom prst="rect">
             <a:avLst/>
@@ -4597,8 +5008,8 @@
         </p:nvSpPr>
         <p:spPr>
           <a:xfrm>
-            <a:off x="6903720" y="1481328"/>
-            <a:ext cx="4434840" cy="347472"/>
+            <a:off x="6903720" y="1481327"/>
+            <a:ext cx="4461718" cy="479089"/>
           </a:xfrm>
           <a:prstGeom prst="rect">
             <a:avLst/>
@@ -4614,7 +5025,7 @@
               <a:buNone/>
             </a:pPr>
             <a:r>
-              <a:rPr lang="en-US" sz="1300" b="1" dirty="0">
+              <a:rPr lang="en-US" b="1" dirty="0">
                 <a:solidFill>
                   <a:srgbClr val="4597D3"/>
                 </a:solidFill>
@@ -4624,7 +5035,7 @@
               </a:rPr>
               <a:t>Tools That Learn Over Time</a:t>
             </a:r>
-            <a:endParaRPr lang="en-US" sz="1300" dirty="0"/>
+            <a:endParaRPr lang="en-US" dirty="0"/>
           </a:p>
         </p:txBody>
       </p:sp>
@@ -4637,7 +5048,7 @@
         <p:spPr>
           <a:xfrm>
             <a:off x="6903720" y="1874520"/>
-            <a:ext cx="4434840" cy="960120"/>
+            <a:ext cx="4461718" cy="1323798"/>
           </a:xfrm>
           <a:prstGeom prst="rect">
             <a:avLst/>
@@ -4656,7 +5067,7 @@
               <a:buNone/>
             </a:pPr>
             <a:r>
-              <a:rPr lang="en-US" sz="1100" dirty="0">
+              <a:rPr lang="en-US" dirty="0">
                 <a:solidFill>
                   <a:srgbClr val="DDDDDD"/>
                 </a:solidFill>
@@ -4666,7 +5077,7 @@
               </a:rPr>
               <a:t>They select platforms with memory, feedback loops, and contextual adaptation — not static point solutions.</a:t>
             </a:r>
-            <a:endParaRPr lang="en-US" sz="1100" dirty="0"/>
+            <a:endParaRPr lang="en-US" dirty="0"/>
           </a:p>
         </p:txBody>
       </p:sp>
@@ -4678,8 +5089,8 @@
         </p:nvSpPr>
         <p:spPr>
           <a:xfrm>
-            <a:off x="365760" y="3063240"/>
-            <a:ext cx="5486400" cy="1572768"/>
+            <a:off x="365759" y="3839100"/>
+            <a:ext cx="5519651" cy="2168508"/>
           </a:xfrm>
           <a:prstGeom prst="rect">
             <a:avLst/>
@@ -4710,8 +5121,8 @@
         </p:nvSpPr>
         <p:spPr>
           <a:xfrm>
-            <a:off x="530352" y="3172968"/>
-            <a:ext cx="640080" cy="457200"/>
+            <a:off x="530351" y="3948828"/>
+            <a:ext cx="643959" cy="630380"/>
           </a:xfrm>
           <a:prstGeom prst="rect">
             <a:avLst/>
@@ -4749,8 +5160,8 @@
         </p:nvSpPr>
         <p:spPr>
           <a:xfrm>
-            <a:off x="1234440" y="3191256"/>
-            <a:ext cx="4434840" cy="347472"/>
+            <a:off x="1234440" y="3967115"/>
+            <a:ext cx="4461718" cy="479089"/>
           </a:xfrm>
           <a:prstGeom prst="rect">
             <a:avLst/>
@@ -4766,7 +5177,7 @@
               <a:buNone/>
             </a:pPr>
             <a:r>
-              <a:rPr lang="en-US" sz="1300" b="1" dirty="0">
+              <a:rPr lang="en-US" b="1" dirty="0">
                 <a:solidFill>
                   <a:srgbClr val="4597D3"/>
                 </a:solidFill>
@@ -4776,7 +5187,7 @@
               </a:rPr>
               <a:t>Vendor-First Strategy</a:t>
             </a:r>
-            <a:endParaRPr lang="en-US" sz="1300" dirty="0"/>
+            <a:endParaRPr lang="en-US" dirty="0"/>
           </a:p>
         </p:txBody>
       </p:sp>
@@ -4788,8 +5199,8 @@
         </p:nvSpPr>
         <p:spPr>
           <a:xfrm>
-            <a:off x="1234440" y="3584448"/>
-            <a:ext cx="4434840" cy="960120"/>
+            <a:off x="1234440" y="4360308"/>
+            <a:ext cx="4461718" cy="1323798"/>
           </a:xfrm>
           <a:prstGeom prst="rect">
             <a:avLst/>
@@ -4808,7 +5219,7 @@
               <a:buNone/>
             </a:pPr>
             <a:r>
-              <a:rPr lang="en-US" sz="1100" dirty="0">
+              <a:rPr lang="en-US" dirty="0">
                 <a:solidFill>
                   <a:srgbClr val="DDDDDD"/>
                 </a:solidFill>
@@ -4818,7 +5229,7 @@
               </a:rPr>
               <a:t>They buy specialized tools and build partnerships rather than defaulting to costly internal engineering builds.</a:t>
             </a:r>
-            <a:endParaRPr lang="en-US" sz="1100" dirty="0"/>
+            <a:endParaRPr lang="en-US" dirty="0"/>
           </a:p>
         </p:txBody>
       </p:sp>
@@ -4830,8 +5241,8 @@
         </p:nvSpPr>
         <p:spPr>
           <a:xfrm>
-            <a:off x="6035040" y="3063240"/>
-            <a:ext cx="5486400" cy="1572768"/>
+            <a:off x="6035039" y="3839100"/>
+            <a:ext cx="5519651" cy="2168508"/>
           </a:xfrm>
           <a:prstGeom prst="rect">
             <a:avLst/>
@@ -4862,8 +5273,8 @@
         </p:nvSpPr>
         <p:spPr>
           <a:xfrm>
-            <a:off x="6199632" y="3172968"/>
-            <a:ext cx="640080" cy="457200"/>
+            <a:off x="6199631" y="3948828"/>
+            <a:ext cx="643959" cy="630380"/>
           </a:xfrm>
           <a:prstGeom prst="rect">
             <a:avLst/>
@@ -4901,8 +5312,8 @@
         </p:nvSpPr>
         <p:spPr>
           <a:xfrm>
-            <a:off x="6903720" y="3191256"/>
-            <a:ext cx="4434840" cy="347472"/>
+            <a:off x="6903720" y="3967115"/>
+            <a:ext cx="4461718" cy="479089"/>
           </a:xfrm>
           <a:prstGeom prst="rect">
             <a:avLst/>
@@ -4918,7 +5329,7 @@
               <a:buNone/>
             </a:pPr>
             <a:r>
-              <a:rPr lang="en-US" sz="1300" b="1" dirty="0">
+              <a:rPr lang="en-US" b="1" dirty="0">
                 <a:solidFill>
                   <a:srgbClr val="4597D3"/>
                 </a:solidFill>
@@ -4928,7 +5339,7 @@
               </a:rPr>
               <a:t>Agentic AI Is Next</a:t>
             </a:r>
-            <a:endParaRPr lang="en-US" sz="1300" dirty="0"/>
+            <a:endParaRPr lang="en-US" dirty="0"/>
           </a:p>
         </p:txBody>
       </p:sp>
@@ -4940,8 +5351,8 @@
         </p:nvSpPr>
         <p:spPr>
           <a:xfrm>
-            <a:off x="6903720" y="3584448"/>
-            <a:ext cx="4434840" cy="960120"/>
+            <a:off x="6903720" y="4360308"/>
+            <a:ext cx="4461718" cy="1323798"/>
           </a:xfrm>
           <a:prstGeom prst="rect">
             <a:avLst/>
@@ -4960,7 +5371,7 @@
               <a:buNone/>
             </a:pPr>
             <a:r>
-              <a:rPr lang="en-US" sz="1100" dirty="0">
+              <a:rPr lang="en-US" dirty="0">
                 <a:solidFill>
                   <a:srgbClr val="DDDDDD"/>
                 </a:solidFill>
@@ -4970,7 +5381,7 @@
               </a:rPr>
               <a:t>NANDA and MCP protocols point to agents that remember and act. Firms investing in agentic infrastructure now will lead in 2026.</a:t>
             </a:r>
-            <a:endParaRPr lang="en-US" sz="1100" dirty="0"/>
+            <a:endParaRPr lang="en-US" dirty="0"/>
           </a:p>
         </p:txBody>
       </p:sp>
@@ -4982,7 +5393,7 @@
         </p:nvSpPr>
         <p:spPr>
           <a:xfrm>
-            <a:off x="457200" y="4754880"/>
+            <a:off x="381000" y="6195753"/>
             <a:ext cx="11430000" cy="201168"/>
           </a:xfrm>
           <a:prstGeom prst="rect">
@@ -5234,7 +5645,7 @@
         <p:spPr>
           <a:xfrm>
             <a:off x="566928" y="1371600"/>
-            <a:ext cx="5212080" cy="215444"/>
+            <a:ext cx="5212080" cy="307777"/>
           </a:xfrm>
           <a:prstGeom prst="rect">
             <a:avLst/>
@@ -5249,7 +5660,7 @@
           <a:p>
             <a:pPr algn="l"/>
             <a:r>
-              <a:rPr sz="1400" b="1" i="0">
+              <a:rPr sz="2000" b="1" i="0" dirty="0">
                 <a:solidFill>
                   <a:schemeClr val="bg1"/>
                 </a:solidFill>
@@ -5269,7 +5680,7 @@
         <p:spPr>
           <a:xfrm>
             <a:off x="594360" y="1801368"/>
-            <a:ext cx="5166360" cy="646331"/>
+            <a:ext cx="5166360" cy="1661993"/>
           </a:xfrm>
           <a:prstGeom prst="rect">
             <a:avLst/>
@@ -5283,35 +5694,62 @@
           <a:lstStyle/>
           <a:p>
             <a:r>
-              <a:rPr sz="1400" b="0" i="0">
+              <a:rPr b="1" i="0" dirty="0">
                 <a:solidFill>
                   <a:srgbClr val="005596"/>
                 </a:solidFill>
                 <a:latin typeface="Calibri"/>
               </a:rPr>
-              <a:t>Challenge: Siloed data across systems blocking real-time apps.</a:t>
-            </a:r>
-          </a:p>
-          <a:p>
-            <a:r>
-              <a:rPr sz="1400" b="0" i="0">
+              <a:t>Challenge:</a:t>
+            </a:r>
+            <a:r>
+              <a:rPr b="0" i="0" dirty="0">
                 <a:solidFill>
                   <a:srgbClr val="005596"/>
                 </a:solidFill>
                 <a:latin typeface="Calibri"/>
               </a:rPr>
-              <a:t>Built: Unified streaming data platform connecting all business systems.</a:t>
-            </a:r>
-          </a:p>
-          <a:p>
-            <a:r>
-              <a:rPr sz="1400" b="0" i="0">
+              <a:t> Siloed data across systems blocking real-time apps.</a:t>
+            </a:r>
+          </a:p>
+          <a:p>
+            <a:r>
+              <a:rPr b="1" i="0" dirty="0">
                 <a:solidFill>
                   <a:srgbClr val="005596"/>
                 </a:solidFill>
                 <a:latin typeface="Calibri"/>
               </a:rPr>
-              <a:t>Outcome: Faster apps, reduced data redundancy, lower third-party costs.</a:t>
+              <a:t>Built:</a:t>
+            </a:r>
+            <a:r>
+              <a:rPr b="0" i="0" dirty="0">
+                <a:solidFill>
+                  <a:srgbClr val="005596"/>
+                </a:solidFill>
+                <a:latin typeface="Calibri"/>
+              </a:rPr>
+              <a:t> Unified streaming data platform connecting all business systems.</a:t>
+            </a:r>
+          </a:p>
+          <a:p>
+            <a:r>
+              <a:rPr b="1" i="0" dirty="0">
+                <a:solidFill>
+                  <a:srgbClr val="005596"/>
+                </a:solidFill>
+                <a:latin typeface="Calibri"/>
+              </a:rPr>
+              <a:t>Outcome:</a:t>
+            </a:r>
+            <a:r>
+              <a:rPr b="0" i="0" dirty="0">
+                <a:solidFill>
+                  <a:srgbClr val="005596"/>
+                </a:solidFill>
+                <a:latin typeface="Calibri"/>
+              </a:rPr>
+              <a:t> Faster apps, reduced data redundancy, lower third-party costs.</a:t>
             </a:r>
           </a:p>
         </p:txBody>
@@ -5413,7 +5851,7 @@
         <p:spPr>
           <a:xfrm>
             <a:off x="6464808" y="1371600"/>
-            <a:ext cx="5212080" cy="215444"/>
+            <a:ext cx="5212080" cy="307777"/>
           </a:xfrm>
           <a:prstGeom prst="rect">
             <a:avLst/>
@@ -5428,7 +5866,7 @@
           <a:p>
             <a:pPr algn="l"/>
             <a:r>
-              <a:rPr sz="1400" b="1" i="0">
+              <a:rPr sz="2000" b="1" i="0">
                 <a:solidFill>
                   <a:schemeClr val="bg1"/>
                 </a:solidFill>
@@ -5448,7 +5886,7 @@
         <p:spPr>
           <a:xfrm>
             <a:off x="6492240" y="1801368"/>
-            <a:ext cx="5166360" cy="646331"/>
+            <a:ext cx="5166360" cy="1661993"/>
           </a:xfrm>
           <a:prstGeom prst="rect">
             <a:avLst/>
@@ -5462,35 +5900,62 @@
           <a:lstStyle/>
           <a:p>
             <a:r>
-              <a:rPr sz="1400" b="0" i="0">
+              <a:rPr b="1" i="0" dirty="0">
                 <a:solidFill>
                   <a:srgbClr val="005596"/>
                 </a:solidFill>
                 <a:latin typeface="Calibri"/>
               </a:rPr>
-              <a:t>Challenge: Clinicians unable to search patient records efficiently.</a:t>
-            </a:r>
-          </a:p>
-          <a:p>
-            <a:r>
-              <a:rPr sz="1400" b="0" i="0">
+              <a:t>Challenge:</a:t>
+            </a:r>
+            <a:r>
+              <a:rPr b="0" i="0" dirty="0">
                 <a:solidFill>
                   <a:srgbClr val="005596"/>
                 </a:solidFill>
                 <a:latin typeface="Calibri"/>
               </a:rPr>
-              <a:t>Built: AI-powered patient records search on Google Cloud.</a:t>
-            </a:r>
-          </a:p>
-          <a:p>
-            <a:r>
-              <a:rPr sz="1400" b="0" i="0">
+              <a:t> Clinicians unable to search patient records efficiently.</a:t>
+            </a:r>
+          </a:p>
+          <a:p>
+            <a:r>
+              <a:rPr b="1" i="0" dirty="0">
                 <a:solidFill>
                   <a:srgbClr val="005596"/>
                 </a:solidFill>
                 <a:latin typeface="Calibri"/>
               </a:rPr>
-              <a:t>Outcome: Faster record access and improved care delivery.</a:t>
+              <a:t>Built:</a:t>
+            </a:r>
+            <a:r>
+              <a:rPr b="0" i="0" dirty="0">
+                <a:solidFill>
+                  <a:srgbClr val="005596"/>
+                </a:solidFill>
+                <a:latin typeface="Calibri"/>
+              </a:rPr>
+              <a:t> AI-powered patient records search on Google Cloud.</a:t>
+            </a:r>
+          </a:p>
+          <a:p>
+            <a:r>
+              <a:rPr b="1" i="0" dirty="0">
+                <a:solidFill>
+                  <a:srgbClr val="005596"/>
+                </a:solidFill>
+                <a:latin typeface="Calibri"/>
+              </a:rPr>
+              <a:t>Outcome:</a:t>
+            </a:r>
+            <a:r>
+              <a:rPr b="0" i="0" dirty="0">
+                <a:solidFill>
+                  <a:srgbClr val="005596"/>
+                </a:solidFill>
+                <a:latin typeface="Calibri"/>
+              </a:rPr>
+              <a:t> Faster record access and improved care delivery.</a:t>
             </a:r>
           </a:p>
         </p:txBody>
@@ -5592,7 +6057,7 @@
         <p:spPr>
           <a:xfrm>
             <a:off x="566928" y="3886200"/>
-            <a:ext cx="5212080" cy="215444"/>
+            <a:ext cx="5212080" cy="307777"/>
           </a:xfrm>
           <a:prstGeom prst="rect">
             <a:avLst/>
@@ -5607,7 +6072,7 @@
           <a:p>
             <a:pPr algn="l"/>
             <a:r>
-              <a:rPr sz="1400" b="1" i="0">
+              <a:rPr sz="2000" b="1" i="0">
                 <a:solidFill>
                   <a:schemeClr val="bg1"/>
                 </a:solidFill>
@@ -5627,7 +6092,7 @@
         <p:spPr>
           <a:xfrm>
             <a:off x="594360" y="4315968"/>
-            <a:ext cx="5166360" cy="646331"/>
+            <a:ext cx="5166360" cy="1661993"/>
           </a:xfrm>
           <a:prstGeom prst="rect">
             <a:avLst/>
@@ -5641,35 +6106,62 @@
           <a:lstStyle/>
           <a:p>
             <a:r>
-              <a:rPr sz="1400" b="0" i="0">
+              <a:rPr b="1" i="0" dirty="0">
                 <a:solidFill>
                   <a:srgbClr val="005596"/>
                 </a:solidFill>
                 <a:latin typeface="Calibri"/>
               </a:rPr>
-              <a:t>Challenge: IT and OT teams unable to share SCADA data in real time.</a:t>
-            </a:r>
-          </a:p>
-          <a:p>
-            <a:r>
-              <a:rPr sz="1400" b="0" i="0">
+              <a:t>Challenge:</a:t>
+            </a:r>
+            <a:r>
+              <a:rPr b="0" i="0" dirty="0">
                 <a:solidFill>
                   <a:srgbClr val="005596"/>
                 </a:solidFill>
                 <a:latin typeface="Calibri"/>
               </a:rPr>
-              <a:t>Built: Azure Medallion data lake integrating operational and business data.</a:t>
-            </a:r>
-          </a:p>
-          <a:p>
-            <a:r>
-              <a:rPr sz="1400" b="0" i="0">
+              <a:t> IT and OT teams unable to share SCADA data in real time.</a:t>
+            </a:r>
+          </a:p>
+          <a:p>
+            <a:r>
+              <a:rPr b="1" i="0" dirty="0">
                 <a:solidFill>
                   <a:srgbClr val="005596"/>
                 </a:solidFill>
                 <a:latin typeface="Calibri"/>
               </a:rPr>
-              <a:t>Outcome: Low-latency replication scaling to millions of daily readings.</a:t>
+              <a:t>Built:</a:t>
+            </a:r>
+            <a:r>
+              <a:rPr b="0" i="0" dirty="0">
+                <a:solidFill>
+                  <a:srgbClr val="005596"/>
+                </a:solidFill>
+                <a:latin typeface="Calibri"/>
+              </a:rPr>
+              <a:t> Azure Medallion data lake integrating operational and business data.</a:t>
+            </a:r>
+          </a:p>
+          <a:p>
+            <a:r>
+              <a:rPr b="1" i="0" dirty="0">
+                <a:solidFill>
+                  <a:srgbClr val="005596"/>
+                </a:solidFill>
+                <a:latin typeface="Calibri"/>
+              </a:rPr>
+              <a:t>Outcome:</a:t>
+            </a:r>
+            <a:r>
+              <a:rPr b="0" i="0" dirty="0">
+                <a:solidFill>
+                  <a:srgbClr val="005596"/>
+                </a:solidFill>
+                <a:latin typeface="Calibri"/>
+              </a:rPr>
+              <a:t> Low-latency replication scaling to millions of daily readings.</a:t>
             </a:r>
           </a:p>
         </p:txBody>
@@ -5771,7 +6263,7 @@
         <p:spPr>
           <a:xfrm>
             <a:off x="6464808" y="3886200"/>
-            <a:ext cx="5212080" cy="215444"/>
+            <a:ext cx="5212080" cy="307777"/>
           </a:xfrm>
           <a:prstGeom prst="rect">
             <a:avLst/>
@@ -5786,7 +6278,7 @@
           <a:p>
             <a:pPr algn="l"/>
             <a:r>
-              <a:rPr sz="1400" b="1" i="0">
+              <a:rPr sz="2000" b="1" i="0">
                 <a:solidFill>
                   <a:schemeClr val="bg1"/>
                 </a:solidFill>
@@ -5806,7 +6298,7 @@
         <p:spPr>
           <a:xfrm>
             <a:off x="6492240" y="4315968"/>
-            <a:ext cx="5166360" cy="646331"/>
+            <a:ext cx="5166360" cy="1661993"/>
           </a:xfrm>
           <a:prstGeom prst="rect">
             <a:avLst/>
@@ -5820,35 +6312,62 @@
           <a:lstStyle/>
           <a:p>
             <a:r>
-              <a:rPr sz="1400" b="0" i="0">
+              <a:rPr b="1" i="0" dirty="0">
                 <a:solidFill>
                   <a:srgbClr val="005596"/>
                 </a:solidFill>
                 <a:latin typeface="Calibri"/>
               </a:rPr>
-              <a:t>Challenge: Legacy data platform costing $50K/month with frequent failures.</a:t>
-            </a:r>
-          </a:p>
-          <a:p>
-            <a:r>
-              <a:rPr sz="1400" b="0" i="0">
+              <a:t>Challenge:</a:t>
+            </a:r>
+            <a:r>
+              <a:rPr b="0" i="0" dirty="0">
                 <a:solidFill>
                   <a:srgbClr val="005596"/>
                 </a:solidFill>
                 <a:latin typeface="Calibri"/>
               </a:rPr>
-              <a:t>Built: Cloud migration enabling real-time analytics and AI capabilities.</a:t>
-            </a:r>
-          </a:p>
-          <a:p>
-            <a:r>
-              <a:rPr sz="1400" b="0" i="0">
+              <a:t> Legacy data platform costing $50K/month with frequent failures.</a:t>
+            </a:r>
+          </a:p>
+          <a:p>
+            <a:r>
+              <a:rPr b="1" i="0" dirty="0">
                 <a:solidFill>
                   <a:srgbClr val="005596"/>
                 </a:solidFill>
                 <a:latin typeface="Calibri"/>
               </a:rPr>
-              <a:t>Outcome: Eliminated legacy costs, improved intelligence-led operations.</a:t>
+              <a:t>Built:</a:t>
+            </a:r>
+            <a:r>
+              <a:rPr b="0" i="0" dirty="0">
+                <a:solidFill>
+                  <a:srgbClr val="005596"/>
+                </a:solidFill>
+                <a:latin typeface="Calibri"/>
+              </a:rPr>
+              <a:t> Cloud migration enabling real-time analytics and AI capabilities.</a:t>
+            </a:r>
+          </a:p>
+          <a:p>
+            <a:r>
+              <a:rPr b="1" i="0" dirty="0">
+                <a:solidFill>
+                  <a:srgbClr val="005596"/>
+                </a:solidFill>
+                <a:latin typeface="Calibri"/>
+              </a:rPr>
+              <a:t>Outcome:</a:t>
+            </a:r>
+            <a:r>
+              <a:rPr b="0" i="0" dirty="0">
+                <a:solidFill>
+                  <a:srgbClr val="005596"/>
+                </a:solidFill>
+                <a:latin typeface="Calibri"/>
+              </a:rPr>
+              <a:t> Eliminated legacy costs, improved intelligence-led operations.</a:t>
             </a:r>
           </a:p>
         </p:txBody>
@@ -7587,76 +8106,6 @@
           </p:txBody>
         </p:sp>
       </p:grpSp>
-      <p:sp>
-        <p:nvSpPr>
-          <p:cNvPr id="13" name="TextBox 12"/>
-          <p:cNvSpPr txBox="1"/>
-          <p:nvPr/>
-        </p:nvSpPr>
-        <p:spPr>
-          <a:xfrm>
-            <a:off x="920459" y="5669358"/>
-            <a:ext cx="9314761" cy="276999"/>
-          </a:xfrm>
-          <a:prstGeom prst="rect">
-            <a:avLst/>
-          </a:prstGeom>
-          <a:noFill/>
-        </p:spPr>
-        <p:txBody>
-          <a:bodyPr wrap="square">
-            <a:spAutoFit/>
-          </a:bodyPr>
-          <a:lstStyle/>
-          <a:p>
-            <a:pPr algn="l"/>
-            <a:r>
-              <a:rPr sz="1200" b="0" i="1" dirty="0">
-                <a:solidFill>
-                  <a:srgbClr val="444444"/>
-                </a:solidFill>
-                <a:latin typeface="Calibri"/>
-              </a:rPr>
-              <a:t>Top use cases: productivity automation · decision support · predictive analytics · customer experience</a:t>
-            </a:r>
-          </a:p>
-        </p:txBody>
-      </p:sp>
-      <p:sp>
-        <p:nvSpPr>
-          <p:cNvPr id="14" name="TextBox 13"/>
-          <p:cNvSpPr txBox="1"/>
-          <p:nvPr/>
-        </p:nvSpPr>
-        <p:spPr>
-          <a:xfrm>
-            <a:off x="920459" y="6032361"/>
-            <a:ext cx="9314761" cy="276999"/>
-          </a:xfrm>
-          <a:prstGeom prst="rect">
-            <a:avLst/>
-          </a:prstGeom>
-          <a:noFill/>
-        </p:spPr>
-        <p:txBody>
-          <a:bodyPr wrap="square">
-            <a:spAutoFit/>
-          </a:bodyPr>
-          <a:lstStyle/>
-          <a:p>
-            <a:pPr algn="l"/>
-            <a:r>
-              <a:rPr sz="1200" b="0" i="1">
-                <a:solidFill>
-                  <a:srgbClr val="444444"/>
-                </a:solidFill>
-                <a:latin typeface="Calibri"/>
-              </a:rPr>
-              <a:t>Leading sectors: financial services, healthcare, manufacturing, energy, public services</a:t>
-            </a:r>
-          </a:p>
-        </p:txBody>
-      </p:sp>
     </p:spTree>
   </p:cSld>
   <p:clrMapOvr>
@@ -11418,6 +11867,15 @@
 </file>
 
 <file path=customXml/item1.xml><?xml version="1.0" encoding="utf-8"?>
+<?mso-contentType ?>
+<FormTemplates xmlns="http://schemas.microsoft.com/sharepoint/v3/contenttype/forms">
+  <Display>DocumentLibraryForm</Display>
+  <Edit>DocumentLibraryForm</Edit>
+  <New>DocumentLibraryForm</New>
+</FormTemplates>
+</file>
+
+<file path=customXml/item2.xml><?xml version="1.0" encoding="utf-8"?>
 <ct:contentTypeSchema xmlns:ct="http://schemas.microsoft.com/office/2006/metadata/contentType" xmlns:ma="http://schemas.microsoft.com/office/2006/metadata/properties/metaAttributes" ct:_="" ma:_="" ma:contentTypeName="Document" ma:contentTypeID="0x010100F341A843C3812949A5F6B27F5EC29832" ma:contentTypeVersion="11" ma:contentTypeDescription="Create a new document." ma:contentTypeScope="" ma:versionID="c7d80cbeb5ee7eef14f2344849123c47">
   <xsd:schema xmlns:xsd="http://www.w3.org/2001/XMLSchema" xmlns:xs="http://www.w3.org/2001/XMLSchema" xmlns:p="http://schemas.microsoft.com/office/2006/metadata/properties" xmlns:ns2="3d5d3f08-0b2c-40bd-a435-45d6327d0872" xmlns:ns3="ec7e3bb3-4c41-4ad0-bd22-cfcb83294da6" targetNamespace="http://schemas.microsoft.com/office/2006/metadata/properties" ma:root="true" ma:fieldsID="6e033a4b47551ef5d4db9884265cb346" ns2:_="" ns3:_="">
     <xsd:import namespace="3d5d3f08-0b2c-40bd-a435-45d6327d0872"/>
@@ -11612,15 +12070,6 @@
 </ct:contentTypeSchema>
 </file>
 
-<file path=customXml/item2.xml><?xml version="1.0" encoding="utf-8"?>
-<?mso-contentType ?>
-<FormTemplates xmlns="http://schemas.microsoft.com/sharepoint/v3/contenttype/forms">
-  <Display>DocumentLibraryForm</Display>
-  <Edit>DocumentLibraryForm</Edit>
-  <New>DocumentLibraryForm</New>
-</FormTemplates>
-</file>
-
 <file path=customXml/item3.xml><?xml version="1.0" encoding="utf-8"?>
 <p:properties xmlns:p="http://schemas.microsoft.com/office/2006/metadata/properties" xmlns:xsi="http://www.w3.org/2001/XMLSchema-instance" xmlns:pc="http://schemas.microsoft.com/office/infopath/2007/PartnerControls">
   <documentManagement>
@@ -11633,6 +12082,14 @@
 </file>
 
 <file path=customXml/itemProps1.xml><?xml version="1.0" encoding="utf-8"?>
+<ds:datastoreItem xmlns:ds="http://schemas.openxmlformats.org/officeDocument/2006/customXml" ds:itemID="{D9CA52EB-0D60-4985-865B-EAD7D03E0ECC}">
+  <ds:schemaRefs>
+    <ds:schemaRef ds:uri="http://schemas.microsoft.com/sharepoint/v3/contenttype/forms"/>
+  </ds:schemaRefs>
+</ds:datastoreItem>
+</file>
+
+<file path=customXml/itemProps2.xml><?xml version="1.0" encoding="utf-8"?>
 <ds:datastoreItem xmlns:ds="http://schemas.openxmlformats.org/officeDocument/2006/customXml" ds:itemID="{C36F2120-FE03-4898-ADAC-861857FEEDC2}">
   <ds:schemaRefs>
     <ds:schemaRef ds:uri="http://schemas.microsoft.com/office/2006/metadata/contentType"/>
@@ -11651,27 +12108,19 @@
 </ds:datastoreItem>
 </file>
 
-<file path=customXml/itemProps2.xml><?xml version="1.0" encoding="utf-8"?>
-<ds:datastoreItem xmlns:ds="http://schemas.openxmlformats.org/officeDocument/2006/customXml" ds:itemID="{D9CA52EB-0D60-4985-865B-EAD7D03E0ECC}">
-  <ds:schemaRefs>
-    <ds:schemaRef ds:uri="http://schemas.microsoft.com/sharepoint/v3/contenttype/forms"/>
-  </ds:schemaRefs>
-</ds:datastoreItem>
-</file>
-
 <file path=customXml/itemProps3.xml><?xml version="1.0" encoding="utf-8"?>
 <ds:datastoreItem xmlns:ds="http://schemas.openxmlformats.org/officeDocument/2006/customXml" ds:itemID="{39BAF3CD-C042-4F87-9416-C829AD0E6787}">
   <ds:schemaRefs>
+    <ds:schemaRef ds:uri="http://purl.org/dc/terms/"/>
+    <ds:schemaRef ds:uri="ec7e3bb3-4c41-4ad0-bd22-cfcb83294da6"/>
+    <ds:schemaRef ds:uri="3d5d3f08-0b2c-40bd-a435-45d6327d0872"/>
+    <ds:schemaRef ds:uri="http://schemas.microsoft.com/office/2006/metadata/properties"/>
+    <ds:schemaRef ds:uri="http://purl.org/dc/dcmitype/"/>
     <ds:schemaRef ds:uri="http://schemas.microsoft.com/office/2006/documentManagement/types"/>
     <ds:schemaRef ds:uri="http://purl.org/dc/elements/1.1/"/>
-    <ds:schemaRef ds:uri="http://schemas.microsoft.com/office/2006/metadata/properties"/>
-    <ds:schemaRef ds:uri="http://purl.org/dc/dcmitype/"/>
+    <ds:schemaRef ds:uri="http://schemas.openxmlformats.org/package/2006/metadata/core-properties"/>
+    <ds:schemaRef ds:uri="http://schemas.microsoft.com/office/infopath/2007/PartnerControls"/>
     <ds:schemaRef ds:uri="http://www.w3.org/XML/1998/namespace"/>
-    <ds:schemaRef ds:uri="http://schemas.openxmlformats.org/package/2006/metadata/core-properties"/>
-    <ds:schemaRef ds:uri="http://purl.org/dc/terms/"/>
-    <ds:schemaRef ds:uri="http://schemas.microsoft.com/office/infopath/2007/PartnerControls"/>
-    <ds:schemaRef ds:uri="ec7e3bb3-4c41-4ad0-bd22-cfcb83294da6"/>
-    <ds:schemaRef ds:uri="3d5d3f08-0b2c-40bd-a435-45d6327d0872"/>
   </ds:schemaRefs>
 </ds:datastoreItem>
 </file>
</xml_diff>